<commit_message>
fix some wording overlap
</commit_message>
<xml_diff>
--- a/docs/job-analytics-hirer-deck.pptx
+++ b/docs/job-analytics-hirer-deck.pptx
@@ -7294,8 +7294,8 @@
         </p:nvSpPr>
         <p:spPr>
           <a:xfrm>
-            <a:off x="3950208" y="2240280"/>
-            <a:ext cx="4251960" cy="310896"/>
+            <a:off x="3950208" y="2167128"/>
+            <a:ext cx="4160520" cy="420624"/>
           </a:xfrm>
           <a:prstGeom prst="rect">
             <a:avLst/>
@@ -7314,11 +7314,11 @@
               </a:lnSpc>
             </a:pPr>
             <a:r>
-              <a:rPr sz="1500" b="0" i="0">
-                <a:solidFill>
-                  <a:srgbClr val="F5F5F5"/>
-                </a:solidFill>
-                <a:latin typeface="Arial"/>
+              <a:rPr sz="1250" b="1">
+                <a:solidFill>
+                  <a:srgbClr val="F2F2F2"/>
+                </a:solidFill>
+                <a:latin typeface="Aptos"/>
               </a:rPr>
               <a:t>Reads as: raise the experience bar, get fewer reposts.</a:t>
             </a:r>
@@ -7333,8 +7333,8 @@
         </p:nvSpPr>
         <p:spPr>
           <a:xfrm>
-            <a:off x="8366760" y="2240280"/>
-            <a:ext cx="2514600" cy="310896"/>
+            <a:off x="8394192" y="2167128"/>
+            <a:ext cx="2395728" cy="420624"/>
           </a:xfrm>
           <a:prstGeom prst="rect">
             <a:avLst/>
@@ -7353,11 +7353,11 @@
               </a:lnSpc>
             </a:pPr>
             <a:r>
-              <a:rPr sz="1500" b="1" i="0">
-                <a:solidFill>
-                  <a:srgbClr val="EF4444"/>
-                </a:solidFill>
-                <a:latin typeface="Arial"/>
+              <a:rPr sz="1250" b="1">
+                <a:solidFill>
+                  <a:srgbClr val="FF4848"/>
+                </a:solidFill>
+                <a:latin typeface="Aptos"/>
               </a:rPr>
               <a:t>True number. Wrong advice.</a:t>
             </a:r>
@@ -7372,8 +7372,8 @@
         </p:nvSpPr>
         <p:spPr>
           <a:xfrm>
-            <a:off x="3950208" y="2615184"/>
-            <a:ext cx="6812280" cy="237744"/>
+            <a:off x="3950208" y="2688336"/>
+            <a:ext cx="6839712" cy="219456"/>
           </a:xfrm>
           <a:prstGeom prst="rect">
             <a:avLst/>
@@ -7392,11 +7392,11 @@
               </a:lnSpc>
             </a:pPr>
             <a:r>
-              <a:rPr sz="1050" b="0" i="0">
-                <a:solidFill>
-                  <a:srgbClr val="A0A0A0"/>
-                </a:solidFill>
-                <a:latin typeface="Arial"/>
+              <a:rPr sz="860" b="0">
+                <a:solidFill>
+                  <a:srgbClr val="AAAAAA"/>
+                </a:solidFill>
+                <a:latin typeface="Aptos"/>
               </a:rPr>
               <a:t>It compares ~$3,000 roles with ~$5,400 roles. The higher-experience group is simply better paid.</a:t>
             </a:r>
@@ -8402,8 +8402,8 @@
         </p:nvSpPr>
         <p:spPr>
           <a:xfrm>
-            <a:off x="7242048" y="3712463"/>
-            <a:ext cx="4279392" cy="1801368"/>
+            <a:off x="7818120" y="3712463"/>
+            <a:ext cx="3703320" cy="1801368"/>
           </a:xfrm>
           <a:prstGeom prst="roundRect">
             <a:avLst/>
@@ -8447,8 +8447,8 @@
         </p:nvSpPr>
         <p:spPr>
           <a:xfrm>
-            <a:off x="7498079" y="3941063"/>
-            <a:ext cx="1554480" cy="219456"/>
+            <a:off x="8065008" y="3941063"/>
+            <a:ext cx="3154680" cy="219456"/>
           </a:xfrm>
           <a:prstGeom prst="rect">
             <a:avLst/>
@@ -8486,8 +8486,8 @@
         </p:nvSpPr>
         <p:spPr>
           <a:xfrm>
-            <a:off x="7498079" y="4160520"/>
-            <a:ext cx="3621024" cy="502920"/>
+            <a:off x="8065008" y="4160520"/>
+            <a:ext cx="3154680" cy="502920"/>
           </a:xfrm>
           <a:prstGeom prst="rect">
             <a:avLst/>
@@ -8525,8 +8525,8 @@
         </p:nvSpPr>
         <p:spPr>
           <a:xfrm>
-            <a:off x="7498079" y="4681728"/>
-            <a:ext cx="3611880" cy="457200"/>
+            <a:off x="8065008" y="4681728"/>
+            <a:ext cx="3154680" cy="457200"/>
           </a:xfrm>
           <a:prstGeom prst="rect">
             <a:avLst/>
@@ -8643,8 +8643,8 @@
         </p:nvSpPr>
         <p:spPr>
           <a:xfrm>
-            <a:off x="7498079" y="5193792"/>
-            <a:ext cx="3611880" cy="201168"/>
+            <a:off x="8065008" y="5193792"/>
+            <a:ext cx="3154680" cy="201168"/>
           </a:xfrm>
           <a:prstGeom prst="rect">
             <a:avLst/>

</xml_diff>

<commit_message>
update slide 6 & 8
</commit_message>
<xml_diff>
--- a/docs/job-analytics-hirer-deck.pptx
+++ b/docs/job-analytics-hirer-deck.pptx
@@ -7294,8 +7294,8 @@
         </p:nvSpPr>
         <p:spPr>
           <a:xfrm>
-            <a:off x="3950208" y="2167128"/>
-            <a:ext cx="4160520" cy="420624"/>
+            <a:off x="3950208" y="2240280"/>
+            <a:ext cx="4279392" cy="310896"/>
           </a:xfrm>
           <a:prstGeom prst="rect">
             <a:avLst/>
@@ -7314,11 +7314,11 @@
               </a:lnSpc>
             </a:pPr>
             <a:r>
-              <a:rPr sz="1250" b="1">
-                <a:solidFill>
-                  <a:srgbClr val="F2F2F2"/>
-                </a:solidFill>
-                <a:latin typeface="Aptos"/>
+              <a:rPr sz="1300" b="0" i="0">
+                <a:solidFill>
+                  <a:srgbClr val="F5F5F5"/>
+                </a:solidFill>
+                <a:latin typeface="Arial"/>
               </a:rPr>
               <a:t>Reads as: raise the experience bar, get fewer reposts.</a:t>
             </a:r>
@@ -7333,8 +7333,8 @@
         </p:nvSpPr>
         <p:spPr>
           <a:xfrm>
-            <a:off x="8394192" y="2167128"/>
-            <a:ext cx="2395728" cy="420624"/>
+            <a:off x="8366760" y="2240280"/>
+            <a:ext cx="2916936" cy="310896"/>
           </a:xfrm>
           <a:prstGeom prst="rect">
             <a:avLst/>
@@ -7353,11 +7353,11 @@
               </a:lnSpc>
             </a:pPr>
             <a:r>
-              <a:rPr sz="1250" b="1">
-                <a:solidFill>
-                  <a:srgbClr val="FF4848"/>
-                </a:solidFill>
-                <a:latin typeface="Aptos"/>
+              <a:rPr sz="1500" b="1" i="0">
+                <a:solidFill>
+                  <a:srgbClr val="EF4444"/>
+                </a:solidFill>
+                <a:latin typeface="Arial"/>
               </a:rPr>
               <a:t>True number. Wrong advice.</a:t>
             </a:r>
@@ -7372,8 +7372,8 @@
         </p:nvSpPr>
         <p:spPr>
           <a:xfrm>
-            <a:off x="3950208" y="2688336"/>
-            <a:ext cx="6839712" cy="219456"/>
+            <a:off x="3950208" y="2615184"/>
+            <a:ext cx="6812280" cy="237744"/>
           </a:xfrm>
           <a:prstGeom prst="rect">
             <a:avLst/>
@@ -7392,11 +7392,11 @@
               </a:lnSpc>
             </a:pPr>
             <a:r>
-              <a:rPr sz="860" b="0">
-                <a:solidFill>
-                  <a:srgbClr val="AAAAAA"/>
-                </a:solidFill>
-                <a:latin typeface="Aptos"/>
+              <a:rPr sz="1050" b="0" i="0">
+                <a:solidFill>
+                  <a:srgbClr val="A0A0A0"/>
+                </a:solidFill>
+                <a:latin typeface="Arial"/>
               </a:rPr>
               <a:t>It compares ~$3,000 roles with ~$5,400 roles. The higher-experience group is simply better paid.</a:t>
             </a:r>
@@ -8402,8 +8402,8 @@
         </p:nvSpPr>
         <p:spPr>
           <a:xfrm>
-            <a:off x="7818120" y="3712463"/>
-            <a:ext cx="3703320" cy="1801368"/>
+            <a:off x="7790688" y="3712463"/>
+            <a:ext cx="3730752" cy="1801368"/>
           </a:xfrm>
           <a:prstGeom prst="roundRect">
             <a:avLst/>
@@ -8447,8 +8447,8 @@
         </p:nvSpPr>
         <p:spPr>
           <a:xfrm>
-            <a:off x="8065008" y="3941063"/>
-            <a:ext cx="3154680" cy="219456"/>
+            <a:off x="8046719" y="3941063"/>
+            <a:ext cx="1554480" cy="219456"/>
           </a:xfrm>
           <a:prstGeom prst="rect">
             <a:avLst/>
@@ -8486,8 +8486,8 @@
         </p:nvSpPr>
         <p:spPr>
           <a:xfrm>
-            <a:off x="8065008" y="4160520"/>
-            <a:ext cx="3154680" cy="502920"/>
+            <a:off x="8046719" y="4160520"/>
+            <a:ext cx="3218690" cy="502920"/>
           </a:xfrm>
           <a:prstGeom prst="rect">
             <a:avLst/>
@@ -8525,8 +8525,8 @@
         </p:nvSpPr>
         <p:spPr>
           <a:xfrm>
-            <a:off x="8065008" y="4681728"/>
-            <a:ext cx="3154680" cy="457200"/>
+            <a:off x="8046719" y="4681728"/>
+            <a:ext cx="3218690" cy="457200"/>
           </a:xfrm>
           <a:prstGeom prst="rect">
             <a:avLst/>
@@ -8643,8 +8643,8 @@
         </p:nvSpPr>
         <p:spPr>
           <a:xfrm>
-            <a:off x="8065008" y="5193792"/>
-            <a:ext cx="3154680" cy="201168"/>
+            <a:off x="8046719" y="5193792"/>
+            <a:ext cx="3218690" cy="201168"/>
           </a:xfrm>
           <a:prstGeom prst="rect">
             <a:avLst/>
@@ -20317,7 +20317,7 @@
                 </a:solidFill>
                 <a:latin typeface="Arial"/>
               </a:rPr>
-              <a:t>CATEGORIES</a:t>
+              <a:t>DATES</a:t>
             </a:r>
           </a:p>
         </p:txBody>
@@ -20356,7 +20356,7 @@
                 </a:solidFill>
                 <a:latin typeface="Arial"/>
               </a:rPr>
-              <a:t>JSON array → explode, not first value</a:t>
+              <a:t>Parse → format back → compare</a:t>
             </a:r>
           </a:p>
         </p:txBody>
@@ -20395,7 +20395,7 @@
                 </a:solidFill>
                 <a:latin typeface="Arial"/>
               </a:rPr>
-              <a:t>43 categories; 37% of postings carry more than one. Keeping only the first would discard 723,000 assignments.</a:t>
+              <a:t>One mismatch and we refuse the conversion. A wrong date is a wrong cohort.</a:t>
             </a:r>
           </a:p>
         </p:txBody>
@@ -20479,7 +20479,7 @@
                 </a:solidFill>
                 <a:latin typeface="Arial"/>
               </a:rPr>
-              <a:t>DATES</a:t>
+              <a:t>TEXT</a:t>
             </a:r>
           </a:p>
         </p:txBody>
@@ -20518,7 +20518,7 @@
                 </a:solidFill>
                 <a:latin typeface="Arial"/>
               </a:rPr>
-              <a:t>Parse → format back → compare</a:t>
+              <a:t>Normalize invisible characters</a:t>
             </a:r>
           </a:p>
         </p:txBody>
@@ -20557,7 +20557,7 @@
                 </a:solidFill>
                 <a:latin typeface="Arial"/>
               </a:rPr>
-              <a:t>One mismatch and we refuse the conversion. A wrong date is a wrong cohort.</a:t>
+              <a:t>Titles carried zero-width characters. \s does not match them. 184 rows: one title can silently become two.</a:t>
             </a:r>
           </a:p>
         </p:txBody>
@@ -20641,7 +20641,7 @@
                 </a:solidFill>
                 <a:latin typeface="Arial"/>
               </a:rPr>
-              <a:t>TEXT</a:t>
+              <a:t>DUPLICATES</a:t>
             </a:r>
           </a:p>
         </p:txBody>
@@ -20680,7 +20680,7 @@
                 </a:solidFill>
                 <a:latin typeface="Arial"/>
               </a:rPr>
-              <a:t>Normalize invisible characters</a:t>
+              <a:t>Flag, don't drop</a:t>
             </a:r>
           </a:p>
         </p:txBody>
@@ -20719,7 +20719,7 @@
                 </a:solidFill>
                 <a:latin typeface="Arial"/>
               </a:rPr>
-              <a:t>Titles carried zero-width characters. \s does not match them. 184 rows: one title can silently become two.</a:t>
+              <a:t>16,990 of 21,344 same-day groups had different view counts. They are real listings, not duplicates to delete.</a:t>
             </a:r>
           </a:p>
         </p:txBody>
@@ -20803,7 +20803,7 @@
                 </a:solidFill>
                 <a:latin typeface="Arial"/>
               </a:rPr>
-              <a:t>DUPLICATES</a:t>
+              <a:t>CATEGORIES</a:t>
             </a:r>
           </a:p>
         </p:txBody>
@@ -20842,7 +20842,7 @@
                 </a:solidFill>
                 <a:latin typeface="Arial"/>
               </a:rPr>
-              <a:t>Flag, don't drop</a:t>
+              <a:t>JSON array → explode, not first value</a:t>
             </a:r>
           </a:p>
         </p:txBody>
@@ -20881,7 +20881,7 @@
                 </a:solidFill>
                 <a:latin typeface="Arial"/>
               </a:rPr>
-              <a:t>16,990 of 21,344 same-day groups had different view counts. They are real listings, not duplicates to delete.</a:t>
+              <a:t>43 categories; 37% of postings carry more than one. Keeping only the first would discard 723,000 assignments.</a:t>
             </a:r>
           </a:p>
         </p:txBody>
@@ -23629,11 +23629,11 @@
               </a:lnSpc>
             </a:pPr>
             <a:r>
-              <a:rPr sz="1500" b="1">
-                <a:solidFill>
-                  <a:srgbClr val="F2F2F2"/>
-                </a:solidFill>
-                <a:latin typeface="Aptos"/>
+              <a:rPr sz="1600" b="1" i="0">
+                <a:solidFill>
+                  <a:srgbClr val="F5F5F5"/>
+                </a:solidFill>
+                <a:latin typeface="Arial"/>
               </a:rPr>
               <a:t>Layer 2 — what response it got</a:t>
             </a:r>
@@ -23668,11 +23668,11 @@
               </a:lnSpc>
             </a:pPr>
             <a:r>
-              <a:rPr sz="1100" b="0">
-                <a:solidFill>
-                  <a:srgbClr val="AAAAAA"/>
-                </a:solidFill>
-                <a:latin typeface="Aptos"/>
+              <a:rPr sz="1100" b="0" i="0">
+                <a:solidFill>
+                  <a:srgbClr val="A0A0A0"/>
+                </a:solidFill>
+                <a:latin typeface="Arial"/>
               </a:rPr>
               <a:t>96,028 30-day listings → repost risk
 78,942 first-cycle listings → views &amp; applications</a:t>

</xml_diff>

<commit_message>
added speaker notes to the deck
</commit_message>
<xml_diff>
--- a/docs/job-analytics-hirer-deck.pptx
+++ b/docs/job-analytics-hirer-deck.pptx
@@ -23,6 +23,1336 @@
   <p:sldSz cx="12192000" cy="6858000"/>
   <p:notesSz cx="7559675" cy="10691813"/>
 </p:presentation>
+</file>
+
+<file path=ppt/notesMasters/notesMaster1.xml><?xml version="1.0" encoding="utf-8"?>
+<p:notesMaster xmlns:a="http://schemas.openxmlformats.org/drawingml/2006/main" xmlns:p="http://schemas.openxmlformats.org/presentationml/2006/main" xmlns:r="http://schemas.openxmlformats.org/officeDocument/2006/relationships">
+  <p:cSld>
+    <p:bg>
+      <p:bgRef idx="1001">
+        <a:schemeClr val="bg1"/>
+      </p:bgRef>
+    </p:bg>
+    <p:spTree>
+      <p:nvGrpSpPr>
+        <p:cNvPr id="1" name=""/>
+        <p:cNvGrpSpPr/>
+        <p:nvPr/>
+      </p:nvGrpSpPr>
+      <p:grpSpPr>
+        <a:xfrm>
+          <a:off x="0" y="0"/>
+          <a:ext cx="0" cy="0"/>
+          <a:chOff x="0" y="0"/>
+          <a:chExt cx="0" cy="0"/>
+        </a:xfrm>
+      </p:grpSpPr>
+      <p:sp>
+        <p:nvSpPr>
+          <p:cNvPr id="2" name="Header Placeholder 1"/>
+          <p:cNvSpPr>
+            <a:spLocks noGrp="1"/>
+          </p:cNvSpPr>
+          <p:nvPr>
+            <p:ph type="hdr" sz="quarter"/>
+          </p:nvPr>
+        </p:nvSpPr>
+        <p:spPr>
+          <a:xfrm>
+            <a:off x="0" y="0"/>
+            <a:ext cx="2971800" cy="457200"/>
+          </a:xfrm>
+          <a:prstGeom prst="rect">
+            <a:avLst/>
+          </a:prstGeom>
+        </p:spPr>
+        <p:txBody>
+          <a:bodyPr vert="horz" lIns="91440" tIns="45720" rIns="91440" bIns="45720" rtlCol="0"/>
+          <a:lstStyle>
+            <a:lvl1pPr algn="l">
+              <a:defRPr sz="1200"/>
+            </a:lvl1pPr>
+          </a:lstStyle>
+          <a:p>
+            <a:endParaRPr lang="en-US"/>
+          </a:p>
+        </p:txBody>
+      </p:sp>
+      <p:sp>
+        <p:nvSpPr>
+          <p:cNvPr id="3" name="Date Placeholder 2"/>
+          <p:cNvSpPr>
+            <a:spLocks noGrp="1"/>
+          </p:cNvSpPr>
+          <p:nvPr>
+            <p:ph type="dt" idx="1"/>
+          </p:nvPr>
+        </p:nvSpPr>
+        <p:spPr>
+          <a:xfrm>
+            <a:off x="3884613" y="0"/>
+            <a:ext cx="2971800" cy="457200"/>
+          </a:xfrm>
+          <a:prstGeom prst="rect">
+            <a:avLst/>
+          </a:prstGeom>
+        </p:spPr>
+        <p:txBody>
+          <a:bodyPr vert="horz" lIns="91440" tIns="45720" rIns="91440" bIns="45720" rtlCol="0"/>
+          <a:lstStyle>
+            <a:lvl1pPr algn="r">
+              <a:defRPr sz="1200"/>
+            </a:lvl1pPr>
+          </a:lstStyle>
+          <a:p>
+            <a:fld id="{0F89C1C7-3DCD-1040-A9CF-14679D8B5DDD}" type="datetimeFigureOut">
+              <a:rPr lang="en-US" smtClean="0"/>
+              <a:t>10/17/16</a:t>
+            </a:fld>
+            <a:endParaRPr lang="en-US"/>
+          </a:p>
+        </p:txBody>
+      </p:sp>
+      <p:sp>
+        <p:nvSpPr>
+          <p:cNvPr id="4" name="Slide Image Placeholder 3"/>
+          <p:cNvSpPr>
+            <a:spLocks noGrp="1" noRot="1" noChangeAspect="1"/>
+          </p:cNvSpPr>
+          <p:nvPr>
+            <p:ph type="sldImg" idx="2"/>
+          </p:nvPr>
+        </p:nvSpPr>
+        <p:spPr>
+          <a:xfrm>
+            <a:off x="1143000" y="685800"/>
+            <a:ext cx="4572000" cy="3429000"/>
+          </a:xfrm>
+          <a:prstGeom prst="rect">
+            <a:avLst/>
+          </a:prstGeom>
+          <a:noFill/>
+          <a:ln w="12700">
+            <a:solidFill>
+              <a:prstClr val="black"/>
+            </a:solidFill>
+          </a:ln>
+        </p:spPr>
+        <p:txBody>
+          <a:bodyPr vert="horz" lIns="91440" tIns="45720" rIns="91440" bIns="45720" rtlCol="0" anchor="ctr"/>
+          <a:lstStyle/>
+          <a:p>
+            <a:endParaRPr lang="en-US"/>
+          </a:p>
+        </p:txBody>
+      </p:sp>
+      <p:sp>
+        <p:nvSpPr>
+          <p:cNvPr id="5" name="Notes Placeholder 4"/>
+          <p:cNvSpPr>
+            <a:spLocks noGrp="1"/>
+          </p:cNvSpPr>
+          <p:nvPr>
+            <p:ph type="body" sz="quarter" idx="3"/>
+          </p:nvPr>
+        </p:nvSpPr>
+        <p:spPr>
+          <a:xfrm>
+            <a:off x="685800" y="4343400"/>
+            <a:ext cx="5486400" cy="4114800"/>
+          </a:xfrm>
+          <a:prstGeom prst="rect">
+            <a:avLst/>
+          </a:prstGeom>
+        </p:spPr>
+        <p:txBody>
+          <a:bodyPr vert="horz" lIns="91440" tIns="45720" rIns="91440" bIns="45720" rtlCol="0"/>
+          <a:lstStyle/>
+          <a:p>
+            <a:pPr lvl="0"/>
+            <a:r>
+              <a:rPr lang="en-US" smtClean="0"/>
+              <a:t>Click to edit Master text styles</a:t>
+            </a:r>
+          </a:p>
+          <a:p>
+            <a:pPr lvl="1"/>
+            <a:r>
+              <a:rPr lang="en-US" smtClean="0"/>
+              <a:t>Second level</a:t>
+            </a:r>
+          </a:p>
+          <a:p>
+            <a:pPr lvl="2"/>
+            <a:r>
+              <a:rPr lang="en-US" smtClean="0"/>
+              <a:t>Third level</a:t>
+            </a:r>
+          </a:p>
+          <a:p>
+            <a:pPr lvl="3"/>
+            <a:r>
+              <a:rPr lang="en-US" smtClean="0"/>
+              <a:t>Fourth level</a:t>
+            </a:r>
+          </a:p>
+          <a:p>
+            <a:pPr lvl="4"/>
+            <a:r>
+              <a:rPr lang="en-US" smtClean="0"/>
+              <a:t>Fifth level</a:t>
+            </a:r>
+            <a:endParaRPr lang="en-US"/>
+          </a:p>
+        </p:txBody>
+      </p:sp>
+      <p:sp>
+        <p:nvSpPr>
+          <p:cNvPr id="6" name="Footer Placeholder 5"/>
+          <p:cNvSpPr>
+            <a:spLocks noGrp="1"/>
+          </p:cNvSpPr>
+          <p:nvPr>
+            <p:ph type="ftr" sz="quarter" idx="4"/>
+          </p:nvPr>
+        </p:nvSpPr>
+        <p:spPr>
+          <a:xfrm>
+            <a:off x="0" y="8685213"/>
+            <a:ext cx="2971800" cy="457200"/>
+          </a:xfrm>
+          <a:prstGeom prst="rect">
+            <a:avLst/>
+          </a:prstGeom>
+        </p:spPr>
+        <p:txBody>
+          <a:bodyPr vert="horz" lIns="91440" tIns="45720" rIns="91440" bIns="45720" rtlCol="0" anchor="b"/>
+          <a:lstStyle>
+            <a:lvl1pPr algn="l">
+              <a:defRPr sz="1200"/>
+            </a:lvl1pPr>
+          </a:lstStyle>
+          <a:p>
+            <a:endParaRPr lang="en-US"/>
+          </a:p>
+        </p:txBody>
+      </p:sp>
+      <p:sp>
+        <p:nvSpPr>
+          <p:cNvPr id="7" name="Slide Number Placeholder 6"/>
+          <p:cNvSpPr>
+            <a:spLocks noGrp="1"/>
+          </p:cNvSpPr>
+          <p:nvPr>
+            <p:ph type="sldNum" sz="quarter" idx="5"/>
+          </p:nvPr>
+        </p:nvSpPr>
+        <p:spPr>
+          <a:xfrm>
+            <a:off x="3884613" y="8685213"/>
+            <a:ext cx="2971800" cy="457200"/>
+          </a:xfrm>
+          <a:prstGeom prst="rect">
+            <a:avLst/>
+          </a:prstGeom>
+        </p:spPr>
+        <p:txBody>
+          <a:bodyPr vert="horz" lIns="91440" tIns="45720" rIns="91440" bIns="45720" rtlCol="0" anchor="b"/>
+          <a:lstStyle>
+            <a:lvl1pPr algn="r">
+              <a:defRPr sz="1200"/>
+            </a:lvl1pPr>
+          </a:lstStyle>
+          <a:p>
+            <a:fld id="{BB5E49A5-4136-284D-997B-48E1D791AD67}" type="slidenum">
+              <a:rPr lang="en-US" smtClean="0"/>
+              <a:t>‹#›</a:t>
+            </a:fld>
+            <a:endParaRPr lang="en-US"/>
+          </a:p>
+        </p:txBody>
+      </p:sp>
+    </p:spTree>
+    <p:extLst>
+      <p:ext uri="{BB962C8B-B14F-4D97-AF65-F5344CB8AC3E}">
+        <p14:creationId xmlns:p14="http://schemas.microsoft.com/office/powerpoint/2010/main" val="2623252185"/>
+      </p:ext>
+    </p:extLst>
+  </p:cSld>
+  <p:clrMap bg1="lt1" tx1="dk1" bg2="lt2" tx2="dk2" accent1="accent1" accent2="accent2" accent3="accent3" accent4="accent4" accent5="accent5" accent6="accent6" hlink="hlink" folHlink="folHlink"/>
+  <p:notesStyle>
+    <a:lvl1pPr marL="0" algn="l" defTabSz="457200" rtl="0" eaLnBrk="1" latinLnBrk="0" hangingPunct="1">
+      <a:defRPr sz="1200" kern="1200">
+        <a:solidFill>
+          <a:schemeClr val="tx1"/>
+        </a:solidFill>
+        <a:latin typeface="+mn-lt"/>
+        <a:ea typeface="+mn-ea"/>
+        <a:cs typeface="+mn-cs"/>
+      </a:defRPr>
+    </a:lvl1pPr>
+    <a:lvl2pPr marL="457200" algn="l" defTabSz="457200" rtl="0" eaLnBrk="1" latinLnBrk="0" hangingPunct="1">
+      <a:defRPr sz="1200" kern="1200">
+        <a:solidFill>
+          <a:schemeClr val="tx1"/>
+        </a:solidFill>
+        <a:latin typeface="+mn-lt"/>
+        <a:ea typeface="+mn-ea"/>
+        <a:cs typeface="+mn-cs"/>
+      </a:defRPr>
+    </a:lvl2pPr>
+    <a:lvl3pPr marL="914400" algn="l" defTabSz="457200" rtl="0" eaLnBrk="1" latinLnBrk="0" hangingPunct="1">
+      <a:defRPr sz="1200" kern="1200">
+        <a:solidFill>
+          <a:schemeClr val="tx1"/>
+        </a:solidFill>
+        <a:latin typeface="+mn-lt"/>
+        <a:ea typeface="+mn-ea"/>
+        <a:cs typeface="+mn-cs"/>
+      </a:defRPr>
+    </a:lvl3pPr>
+    <a:lvl4pPr marL="1371600" algn="l" defTabSz="457200" rtl="0" eaLnBrk="1" latinLnBrk="0" hangingPunct="1">
+      <a:defRPr sz="1200" kern="1200">
+        <a:solidFill>
+          <a:schemeClr val="tx1"/>
+        </a:solidFill>
+        <a:latin typeface="+mn-lt"/>
+        <a:ea typeface="+mn-ea"/>
+        <a:cs typeface="+mn-cs"/>
+      </a:defRPr>
+    </a:lvl4pPr>
+    <a:lvl5pPr marL="1828800" algn="l" defTabSz="457200" rtl="0" eaLnBrk="1" latinLnBrk="0" hangingPunct="1">
+      <a:defRPr sz="1200" kern="1200">
+        <a:solidFill>
+          <a:schemeClr val="tx1"/>
+        </a:solidFill>
+        <a:latin typeface="+mn-lt"/>
+        <a:ea typeface="+mn-ea"/>
+        <a:cs typeface="+mn-cs"/>
+      </a:defRPr>
+    </a:lvl5pPr>
+    <a:lvl6pPr marL="2286000" algn="l" defTabSz="457200" rtl="0" eaLnBrk="1" latinLnBrk="0" hangingPunct="1">
+      <a:defRPr sz="1200" kern="1200">
+        <a:solidFill>
+          <a:schemeClr val="tx1"/>
+        </a:solidFill>
+        <a:latin typeface="+mn-lt"/>
+        <a:ea typeface="+mn-ea"/>
+        <a:cs typeface="+mn-cs"/>
+      </a:defRPr>
+    </a:lvl6pPr>
+    <a:lvl7pPr marL="2743200" algn="l" defTabSz="457200" rtl="0" eaLnBrk="1" latinLnBrk="0" hangingPunct="1">
+      <a:defRPr sz="1200" kern="1200">
+        <a:solidFill>
+          <a:schemeClr val="tx1"/>
+        </a:solidFill>
+        <a:latin typeface="+mn-lt"/>
+        <a:ea typeface="+mn-ea"/>
+        <a:cs typeface="+mn-cs"/>
+      </a:defRPr>
+    </a:lvl7pPr>
+    <a:lvl8pPr marL="3200400" algn="l" defTabSz="457200" rtl="0" eaLnBrk="1" latinLnBrk="0" hangingPunct="1">
+      <a:defRPr sz="1200" kern="1200">
+        <a:solidFill>
+          <a:schemeClr val="tx1"/>
+        </a:solidFill>
+        <a:latin typeface="+mn-lt"/>
+        <a:ea typeface="+mn-ea"/>
+        <a:cs typeface="+mn-cs"/>
+      </a:defRPr>
+    </a:lvl8pPr>
+    <a:lvl9pPr marL="3657600" algn="l" defTabSz="457200" rtl="0" eaLnBrk="1" latinLnBrk="0" hangingPunct="1">
+      <a:defRPr sz="1200" kern="1200">
+        <a:solidFill>
+          <a:schemeClr val="tx1"/>
+        </a:solidFill>
+        <a:latin typeface="+mn-lt"/>
+        <a:ea typeface="+mn-ea"/>
+        <a:cs typeface="+mn-cs"/>
+      </a:defRPr>
+    </a:lvl9pPr>
+  </p:notesStyle>
+</p:notesMaster>
+</file>
+
+<file path=ppt/notesSlides/notesSlide1.xml><?xml version="1.0" encoding="utf-8"?>
+<p:notes xmlns:a="http://schemas.openxmlformats.org/drawingml/2006/main" xmlns:p="http://schemas.openxmlformats.org/presentationml/2006/main" xmlns:r="http://schemas.openxmlformats.org/officeDocument/2006/relationships">
+  <p:cSld>
+    <p:spTree>
+      <p:nvGrpSpPr>
+        <p:cNvPr id="1" name=""/>
+        <p:cNvGrpSpPr/>
+        <p:nvPr/>
+      </p:nvGrpSpPr>
+      <p:grpSpPr>
+        <a:xfrm>
+          <a:off x="0" y="0"/>
+          <a:ext cx="0" cy="0"/>
+          <a:chOff x="0" y="0"/>
+          <a:chExt cx="0" cy="0"/>
+        </a:xfrm>
+      </p:grpSpPr>
+      <p:sp>
+        <p:nvSpPr>
+          <p:cNvPr id="2" name="Slide Image Placeholder 1"/>
+          <p:cNvSpPr>
+            <a:spLocks noGrp="1"/>
+          </p:cNvSpPr>
+          <p:nvPr>
+            <p:ph type="sldImg" idx="2"/>
+          </p:nvPr>
+        </p:nvSpPr>
+        <p:spPr/>
+      </p:sp>
+      <p:sp>
+        <p:nvSpPr>
+          <p:cNvPr id="3" name="Notes Placeholder 2"/>
+          <p:cNvSpPr>
+            <a:spLocks noGrp="1"/>
+          </p:cNvSpPr>
+          <p:nvPr>
+            <p:ph type="body" idx="3" sz="quarter"/>
+          </p:nvPr>
+        </p:nvSpPr>
+        <p:spPr/>
+        <p:txBody>
+          <a:bodyPr/>
+          <a:lstStyle/>
+          <a:p>
+            <a:r>
+              <a:t>[SEGMENT 1 - Business case, budget 2:00] [~15s] Singapore Jobs Analytics: Before You Post - a decision tool for the hiring side of the market. Built on 1.04 million postings, March 2023 to May 2024, on Streamlit and DuckDB.</a:t>
+            </a:r>
+          </a:p>
+        </p:txBody>
+      </p:sp>
+      <p:sp>
+        <p:nvSpPr>
+          <p:cNvPr id="4" name="Slide Number Placeholder 3"/>
+          <p:cNvSpPr>
+            <a:spLocks noGrp="1"/>
+          </p:cNvSpPr>
+          <p:nvPr>
+            <p:ph type="sldNum" idx="5" sz="quarter"/>
+          </p:nvPr>
+        </p:nvSpPr>
+        <p:spPr/>
+      </p:sp>
+    </p:spTree>
+  </p:cSld>
+  <p:clrMapOvr>
+    <a:masterClrMapping/>
+  </p:clrMapOvr>
+</p:notes>
+</file>
+
+<file path=ppt/notesSlides/notesSlide10.xml><?xml version="1.0" encoding="utf-8"?>
+<p:notes xmlns:a="http://schemas.openxmlformats.org/drawingml/2006/main" xmlns:p="http://schemas.openxmlformats.org/presentationml/2006/main" xmlns:r="http://schemas.openxmlformats.org/officeDocument/2006/relationships">
+  <p:cSld>
+    <p:spTree>
+      <p:nvGrpSpPr>
+        <p:cNvPr id="1" name=""/>
+        <p:cNvGrpSpPr/>
+        <p:nvPr/>
+      </p:nvGrpSpPr>
+      <p:grpSpPr>
+        <a:xfrm>
+          <a:off x="0" y="0"/>
+          <a:ext cx="0" cy="0"/>
+          <a:chOff x="0" y="0"/>
+          <a:chExt cx="0" cy="0"/>
+        </a:xfrm>
+      </p:grpSpPr>
+      <p:sp>
+        <p:nvSpPr>
+          <p:cNvPr id="2" name="Slide Image Placeholder 1"/>
+          <p:cNvSpPr>
+            <a:spLocks noGrp="1"/>
+          </p:cNvSpPr>
+          <p:nvPr>
+            <p:ph type="sldImg" idx="2"/>
+          </p:nvPr>
+        </p:nvSpPr>
+        <p:spPr/>
+      </p:sp>
+      <p:sp>
+        <p:nvSpPr>
+          <p:cNvPr id="3" name="Notes Placeholder 2"/>
+          <p:cNvSpPr>
+            <a:spLocks noGrp="1"/>
+          </p:cNvSpPr>
+          <p:nvPr>
+            <p:ph type="body" idx="3" sz="quarter"/>
+          </p:nvPr>
+        </p:nvSpPr>
+        <p:spPr/>
+        <p:txBody>
+          <a:bodyPr/>
+          <a:lstStyle/>
+          <a:p>
+            <a:r>
+              <a:t>[SEGMENT 3 - Dashboard walkthrough, budget 3:45] [~20s script + ~85s live demo = ~105s block] That's the foundation - now the live app. Five tabs, five decisions in one hirer workflow: salary benchmark, experience norms, applicant response, reach vs conversion, repost risk. SWITCH TO LIVE DEMO HERE - budget about 85 seconds. Prioritize the Repost Risk tab since slide 12 is its payoff; move quickly through the other four.</a:t>
+            </a:r>
+          </a:p>
+        </p:txBody>
+      </p:sp>
+      <p:sp>
+        <p:nvSpPr>
+          <p:cNvPr id="4" name="Slide Number Placeholder 3"/>
+          <p:cNvSpPr>
+            <a:spLocks noGrp="1"/>
+          </p:cNvSpPr>
+          <p:nvPr>
+            <p:ph type="sldNum" idx="5" sz="quarter"/>
+          </p:nvPr>
+        </p:nvSpPr>
+        <p:spPr/>
+      </p:sp>
+    </p:spTree>
+  </p:cSld>
+  <p:clrMapOvr>
+    <a:masterClrMapping/>
+  </p:clrMapOvr>
+</p:notes>
+</file>
+
+<file path=ppt/notesSlides/notesSlide11.xml><?xml version="1.0" encoding="utf-8"?>
+<p:notes xmlns:a="http://schemas.openxmlformats.org/drawingml/2006/main" xmlns:p="http://schemas.openxmlformats.org/presentationml/2006/main" xmlns:r="http://schemas.openxmlformats.org/officeDocument/2006/relationships">
+  <p:cSld>
+    <p:spTree>
+      <p:nvGrpSpPr>
+        <p:cNvPr id="1" name=""/>
+        <p:cNvGrpSpPr/>
+        <p:nvPr/>
+      </p:nvGrpSpPr>
+      <p:grpSpPr>
+        <a:xfrm>
+          <a:off x="0" y="0"/>
+          <a:ext cx="0" cy="0"/>
+          <a:chOff x="0" y="0"/>
+          <a:chExt cx="0" cy="0"/>
+        </a:xfrm>
+      </p:grpSpPr>
+      <p:sp>
+        <p:nvSpPr>
+          <p:cNvPr id="2" name="Slide Image Placeholder 1"/>
+          <p:cNvSpPr>
+            <a:spLocks noGrp="1"/>
+          </p:cNvSpPr>
+          <p:nvPr>
+            <p:ph type="sldImg" idx="2"/>
+          </p:nvPr>
+        </p:nvSpPr>
+        <p:spPr/>
+      </p:sp>
+      <p:sp>
+        <p:nvSpPr>
+          <p:cNvPr id="3" name="Notes Placeholder 2"/>
+          <p:cNvSpPr>
+            <a:spLocks noGrp="1"/>
+          </p:cNvSpPr>
+          <p:nvPr>
+            <p:ph type="body" idx="3" sz="quarter"/>
+          </p:nvPr>
+        </p:nvSpPr>
+        <p:spPr/>
+        <p:txBody>
+          <a:bodyPr/>
+          <a:lstStyle/>
+          <a:p>
+            <a:r>
+              <a:t>[~40s] Low pay costs twice. Entry roles draw a median of 2 applications and a 43.3% under-fill rate; by executive, that's 10 applications and 12.6%. Worth saying out loud: median is 3, but the mean is 9.6 - quoting averages would set expectations three times too high. And entry roles get about half the views of exec roles - 53 versus 116 - and convert at about a third the rate - 3.2% versus 8.9%. Two problems compounding, not one. Based on 78,430 postings with a valid pay band, Mar-Jun 2023.</a:t>
+            </a:r>
+          </a:p>
+        </p:txBody>
+      </p:sp>
+      <p:sp>
+        <p:nvSpPr>
+          <p:cNvPr id="4" name="Slide Number Placeholder 3"/>
+          <p:cNvSpPr>
+            <a:spLocks noGrp="1"/>
+          </p:cNvSpPr>
+          <p:nvPr>
+            <p:ph type="sldNum" idx="5" sz="quarter"/>
+          </p:nvPr>
+        </p:nvSpPr>
+        <p:spPr/>
+      </p:sp>
+    </p:spTree>
+  </p:cSld>
+  <p:clrMapOvr>
+    <a:masterClrMapping/>
+  </p:clrMapOvr>
+</p:notes>
+</file>
+
+<file path=ppt/notesSlides/notesSlide12.xml><?xml version="1.0" encoding="utf-8"?>
+<p:notes xmlns:a="http://schemas.openxmlformats.org/drawingml/2006/main" xmlns:p="http://schemas.openxmlformats.org/presentationml/2006/main" xmlns:r="http://schemas.openxmlformats.org/officeDocument/2006/relationships">
+  <p:cSld>
+    <p:spTree>
+      <p:nvGrpSpPr>
+        <p:cNvPr id="1" name=""/>
+        <p:cNvGrpSpPr/>
+        <p:nvPr/>
+      </p:nvGrpSpPr>
+      <p:grpSpPr>
+        <a:xfrm>
+          <a:off x="0" y="0"/>
+          <a:ext cx="0" cy="0"/>
+          <a:chOff x="0" y="0"/>
+          <a:chExt cx="0" cy="0"/>
+        </a:xfrm>
+      </p:grpSpPr>
+      <p:sp>
+        <p:nvSpPr>
+          <p:cNvPr id="2" name="Slide Image Placeholder 1"/>
+          <p:cNvSpPr>
+            <a:spLocks noGrp="1"/>
+          </p:cNvSpPr>
+          <p:nvPr>
+            <p:ph type="sldImg" idx="2"/>
+          </p:nvPr>
+        </p:nvSpPr>
+        <p:spPr/>
+      </p:sp>
+      <p:sp>
+        <p:nvSpPr>
+          <p:cNvPr id="3" name="Notes Placeholder 2"/>
+          <p:cNvSpPr>
+            <a:spLocks noGrp="1"/>
+          </p:cNvSpPr>
+          <p:nvPr>
+            <p:ph type="body" idx="3" sz="quarter"/>
+          </p:nvPr>
+        </p:nvSpPr>
+        <p:spPr/>
+        <p:txBody>
+          <a:bodyPr/>
+          <a:lstStyle/>
+          <a:p>
+            <a:r>
+              <a:t>[~75s - the payoff slide, do not rush] Aggregate data lies here. Market-wide, reposting falls from 18.7% to 16.2% as the experience ask rises past 3 years - reads as 'raise the bar, get fewer reposts.' True number, wrong advice: it's comparing $3,000 roles to $5,400 roles - pay is doing the work. Split by pay band instead: at Entry, under $3k, asking 3-plus years actually raises reposting by 5.3 points, 19.4% to 24.6%. Every other band goes the other way - Mid roughly flat, Senior down 2.4 points, Exec down 2.9. This isn't noise - Breslow-Day p is about 6 times ten-to-the-minus-12, odds ratio 1.36, 95% CI 1.23 to 1.51, on 95,289 postings with a valid pay band. That's why the board never shows the unstratified view.</a:t>
+            </a:r>
+          </a:p>
+        </p:txBody>
+      </p:sp>
+      <p:sp>
+        <p:nvSpPr>
+          <p:cNvPr id="4" name="Slide Number Placeholder 3"/>
+          <p:cNvSpPr>
+            <a:spLocks noGrp="1"/>
+          </p:cNvSpPr>
+          <p:nvPr>
+            <p:ph type="sldNum" idx="5" sz="quarter"/>
+          </p:nvPr>
+        </p:nvSpPr>
+        <p:spPr/>
+      </p:sp>
+    </p:spTree>
+  </p:cSld>
+  <p:clrMapOvr>
+    <a:masterClrMapping/>
+  </p:clrMapOvr>
+</p:notes>
+</file>
+
+<file path=ppt/notesSlides/notesSlide13.xml><?xml version="1.0" encoding="utf-8"?>
+<p:notes xmlns:a="http://schemas.openxmlformats.org/drawingml/2006/main" xmlns:p="http://schemas.openxmlformats.org/presentationml/2006/main" xmlns:r="http://schemas.openxmlformats.org/officeDocument/2006/relationships">
+  <p:cSld>
+    <p:spTree>
+      <p:nvGrpSpPr>
+        <p:cNvPr id="1" name=""/>
+        <p:cNvGrpSpPr/>
+        <p:nvPr/>
+      </p:nvGrpSpPr>
+      <p:grpSpPr>
+        <a:xfrm>
+          <a:off x="0" y="0"/>
+          <a:ext cx="0" cy="0"/>
+          <a:chOff x="0" y="0"/>
+          <a:chExt cx="0" cy="0"/>
+        </a:xfrm>
+      </p:grpSpPr>
+      <p:sp>
+        <p:nvSpPr>
+          <p:cNvPr id="2" name="Slide Image Placeholder 1"/>
+          <p:cNvSpPr>
+            <a:spLocks noGrp="1"/>
+          </p:cNvSpPr>
+          <p:nvPr>
+            <p:ph type="sldImg" idx="2"/>
+          </p:nvPr>
+        </p:nvSpPr>
+        <p:spPr/>
+      </p:sp>
+      <p:sp>
+        <p:nvSpPr>
+          <p:cNvPr id="3" name="Notes Placeholder 2"/>
+          <p:cNvSpPr>
+            <a:spLocks noGrp="1"/>
+          </p:cNvSpPr>
+          <p:nvPr>
+            <p:ph type="body" idx="3" sz="quarter"/>
+          </p:nvPr>
+        </p:nvSpPr>
+        <p:spPr/>
+        <p:txBody>
+          <a:bodyPr/>
+          <a:lstStyle/>
+          <a:p>
+            <a:r>
+              <a:t>[SEGMENT 4 - Challenges &amp; learnings, budget 1:00 for slides 13+14] [~35s] Three fast lessons. Earning the right to use 78,942 rows instead of a million was the hard part - that's the difference between a number and a trustworthy one. Two features got built and deleted along the way - skill_count and competitiveness_score - a weak proxy is worse than no proxy. And nothing here claims causation or that a role actually filled - one open thread: high-volume employers see markedly less engagement per posting, rho about minus 0.53.</a:t>
+            </a:r>
+          </a:p>
+        </p:txBody>
+      </p:sp>
+      <p:sp>
+        <p:nvSpPr>
+          <p:cNvPr id="4" name="Slide Number Placeholder 3"/>
+          <p:cNvSpPr>
+            <a:spLocks noGrp="1"/>
+          </p:cNvSpPr>
+          <p:nvPr>
+            <p:ph type="sldNum" idx="5" sz="quarter"/>
+          </p:nvPr>
+        </p:nvSpPr>
+        <p:spPr/>
+      </p:sp>
+    </p:spTree>
+  </p:cSld>
+  <p:clrMapOvr>
+    <a:masterClrMapping/>
+  </p:clrMapOvr>
+</p:notes>
+</file>
+
+<file path=ppt/notesSlides/notesSlide14.xml><?xml version="1.0" encoding="utf-8"?>
+<p:notes xmlns:a="http://schemas.openxmlformats.org/drawingml/2006/main" xmlns:p="http://schemas.openxmlformats.org/presentationml/2006/main" xmlns:r="http://schemas.openxmlformats.org/officeDocument/2006/relationships">
+  <p:cSld>
+    <p:spTree>
+      <p:nvGrpSpPr>
+        <p:cNvPr id="1" name=""/>
+        <p:cNvGrpSpPr/>
+        <p:nvPr/>
+      </p:nvGrpSpPr>
+      <p:grpSpPr>
+        <a:xfrm>
+          <a:off x="0" y="0"/>
+          <a:ext cx="0" cy="0"/>
+          <a:chOff x="0" y="0"/>
+          <a:chExt cx="0" cy="0"/>
+        </a:xfrm>
+      </p:grpSpPr>
+      <p:sp>
+        <p:nvSpPr>
+          <p:cNvPr id="2" name="Slide Image Placeholder 1"/>
+          <p:cNvSpPr>
+            <a:spLocks noGrp="1"/>
+          </p:cNvSpPr>
+          <p:nvPr>
+            <p:ph type="sldImg" idx="2"/>
+          </p:nvPr>
+        </p:nvSpPr>
+        <p:spPr/>
+      </p:sp>
+      <p:sp>
+        <p:nvSpPr>
+          <p:cNvPr id="3" name="Notes Placeholder 2"/>
+          <p:cNvSpPr>
+            <a:spLocks noGrp="1"/>
+          </p:cNvSpPr>
+          <p:nvPr>
+            <p:ph type="body" idx="3" sz="quarter"/>
+          </p:nvPr>
+        </p:nvSpPr>
+        <p:spPr/>
+        <p:txBody>
+          <a:bodyPr/>
+          <a:lstStyle/>
+          <a:p>
+            <a:r>
+              <a:t>[~25s] So: three checks before you post. Is the pay competitive against comparable roles, not the whole market? Is the experience ask normal? And what response should you realistically expect, from fully observed postings only? The clearest risk zone here is low pay paired with a high experience ask. One board, one vacancy, three checks before you post. Thank you.</a:t>
+            </a:r>
+          </a:p>
+        </p:txBody>
+      </p:sp>
+      <p:sp>
+        <p:nvSpPr>
+          <p:cNvPr id="4" name="Slide Number Placeholder 3"/>
+          <p:cNvSpPr>
+            <a:spLocks noGrp="1"/>
+          </p:cNvSpPr>
+          <p:nvPr>
+            <p:ph type="sldNum" idx="5" sz="quarter"/>
+          </p:nvPr>
+        </p:nvSpPr>
+        <p:spPr/>
+      </p:sp>
+    </p:spTree>
+  </p:cSld>
+  <p:clrMapOvr>
+    <a:masterClrMapping/>
+  </p:clrMapOvr>
+</p:notes>
+</file>
+
+<file path=ppt/notesSlides/notesSlide2.xml><?xml version="1.0" encoding="utf-8"?>
+<p:notes xmlns:a="http://schemas.openxmlformats.org/drawingml/2006/main" xmlns:p="http://schemas.openxmlformats.org/presentationml/2006/main" xmlns:r="http://schemas.openxmlformats.org/officeDocument/2006/relationships">
+  <p:cSld>
+    <p:spTree>
+      <p:nvGrpSpPr>
+        <p:cNvPr id="1" name=""/>
+        <p:cNvGrpSpPr/>
+        <p:nvPr/>
+      </p:nvGrpSpPr>
+      <p:grpSpPr>
+        <a:xfrm>
+          <a:off x="0" y="0"/>
+          <a:ext cx="0" cy="0"/>
+          <a:chOff x="0" y="0"/>
+          <a:chExt cx="0" cy="0"/>
+        </a:xfrm>
+      </p:grpSpPr>
+      <p:sp>
+        <p:nvSpPr>
+          <p:cNvPr id="2" name="Slide Image Placeholder 1"/>
+          <p:cNvSpPr>
+            <a:spLocks noGrp="1"/>
+          </p:cNvSpPr>
+          <p:nvPr>
+            <p:ph type="sldImg" idx="2"/>
+          </p:nvPr>
+        </p:nvSpPr>
+        <p:spPr/>
+      </p:sp>
+      <p:sp>
+        <p:nvSpPr>
+          <p:cNvPr id="3" name="Notes Placeholder 2"/>
+          <p:cNvSpPr>
+            <a:spLocks noGrp="1"/>
+          </p:cNvSpPr>
+          <p:nvPr>
+            <p:ph type="body" idx="3" sz="quarter"/>
+          </p:nvPr>
+        </p:nvSpPr>
+        <p:spPr/>
+        <p:txBody>
+          <a:bodyPr/>
+          <a:lstStyle/>
+          <a:p>
+            <a:r>
+              <a:t>[~30s] The hirer sets three things - pay range, minimum years, position level - with no reliable benchmark. Today they decide from what they paid last time, or a colleague's guess - no reference point. That costs real money: 30% of postings end up under-filled, 17.8% get reposted. The question this tool answers: before I post, is my offer competitive, and what response should I realistically expect?</a:t>
+            </a:r>
+          </a:p>
+        </p:txBody>
+      </p:sp>
+      <p:sp>
+        <p:nvSpPr>
+          <p:cNvPr id="4" name="Slide Number Placeholder 3"/>
+          <p:cNvSpPr>
+            <a:spLocks noGrp="1"/>
+          </p:cNvSpPr>
+          <p:nvPr>
+            <p:ph type="sldNum" idx="5" sz="quarter"/>
+          </p:nvPr>
+        </p:nvSpPr>
+        <p:spPr/>
+      </p:sp>
+    </p:spTree>
+  </p:cSld>
+  <p:clrMapOvr>
+    <a:masterClrMapping/>
+  </p:clrMapOvr>
+</p:notes>
+</file>
+
+<file path=ppt/notesSlides/notesSlide3.xml><?xml version="1.0" encoding="utf-8"?>
+<p:notes xmlns:a="http://schemas.openxmlformats.org/drawingml/2006/main" xmlns:p="http://schemas.openxmlformats.org/presentationml/2006/main" xmlns:r="http://schemas.openxmlformats.org/officeDocument/2006/relationships">
+  <p:cSld>
+    <p:spTree>
+      <p:nvGrpSpPr>
+        <p:cNvPr id="1" name=""/>
+        <p:cNvGrpSpPr/>
+        <p:nvPr/>
+      </p:nvGrpSpPr>
+      <p:grpSpPr>
+        <a:xfrm>
+          <a:off x="0" y="0"/>
+          <a:ext cx="0" cy="0"/>
+          <a:chOff x="0" y="0"/>
+          <a:chExt cx="0" cy="0"/>
+        </a:xfrm>
+      </p:grpSpPr>
+      <p:sp>
+        <p:nvSpPr>
+          <p:cNvPr id="2" name="Slide Image Placeholder 1"/>
+          <p:cNvSpPr>
+            <a:spLocks noGrp="1"/>
+          </p:cNvSpPr>
+          <p:nvPr>
+            <p:ph type="sldImg" idx="2"/>
+          </p:nvPr>
+        </p:nvSpPr>
+        <p:spPr/>
+      </p:sp>
+      <p:sp>
+        <p:nvSpPr>
+          <p:cNvPr id="3" name="Notes Placeholder 2"/>
+          <p:cNvSpPr>
+            <a:spLocks noGrp="1"/>
+          </p:cNvSpPr>
+          <p:nvPr>
+            <p:ph type="body" idx="3" sz="quarter"/>
+          </p:nvPr>
+        </p:nvSpPr>
+        <p:spPr/>
+        <p:txBody>
+          <a:bodyPr/>
+          <a:lstStyle/>
+          <a:p>
+            <a:r>
+              <a:t>[~25s] What a posting SAYS - pay, level, years, dates - is fixed the moment it goes live; we have all 1.04 million rows of it. What it GOT - views, applications, reposts - only accumulates afterward, and only a subset can measure it reliably. Same dataset, different evidentiary limits - that split shapes everything from here on.</a:t>
+            </a:r>
+          </a:p>
+        </p:txBody>
+      </p:sp>
+      <p:sp>
+        <p:nvSpPr>
+          <p:cNvPr id="4" name="Slide Number Placeholder 3"/>
+          <p:cNvSpPr>
+            <a:spLocks noGrp="1"/>
+          </p:cNvSpPr>
+          <p:nvPr>
+            <p:ph type="sldNum" idx="5" sz="quarter"/>
+          </p:nvPr>
+        </p:nvSpPr>
+        <p:spPr/>
+      </p:sp>
+    </p:spTree>
+  </p:cSld>
+  <p:clrMapOvr>
+    <a:masterClrMapping/>
+  </p:clrMapOvr>
+</p:notes>
+</file>
+
+<file path=ppt/notesSlides/notesSlide4.xml><?xml version="1.0" encoding="utf-8"?>
+<p:notes xmlns:a="http://schemas.openxmlformats.org/drawingml/2006/main" xmlns:p="http://schemas.openxmlformats.org/presentationml/2006/main" xmlns:r="http://schemas.openxmlformats.org/officeDocument/2006/relationships">
+  <p:cSld>
+    <p:spTree>
+      <p:nvGrpSpPr>
+        <p:cNvPr id="1" name=""/>
+        <p:cNvGrpSpPr/>
+        <p:nvPr/>
+      </p:nvGrpSpPr>
+      <p:grpSpPr>
+        <a:xfrm>
+          <a:off x="0" y="0"/>
+          <a:ext cx="0" cy="0"/>
+          <a:chOff x="0" y="0"/>
+          <a:chExt cx="0" cy="0"/>
+        </a:xfrm>
+      </p:grpSpPr>
+      <p:sp>
+        <p:nvSpPr>
+          <p:cNvPr id="2" name="Slide Image Placeholder 1"/>
+          <p:cNvSpPr>
+            <a:spLocks noGrp="1"/>
+          </p:cNvSpPr>
+          <p:nvPr>
+            <p:ph type="sldImg" idx="2"/>
+          </p:nvPr>
+        </p:nvSpPr>
+        <p:spPr/>
+      </p:sp>
+      <p:sp>
+        <p:nvSpPr>
+          <p:cNvPr id="3" name="Notes Placeholder 2"/>
+          <p:cNvSpPr>
+            <a:spLocks noGrp="1"/>
+          </p:cNvSpPr>
+          <p:nvPr>
+            <p:ph type="body" idx="3" sz="quarter"/>
+          </p:nvPr>
+        </p:nvSpPr>
+        <p:spPr/>
+        <p:txBody>
+          <a:bodyPr/>
+          <a:lstStyle/>
+          <a:p>
+            <a:r>
+              <a:t>[SEGMENT 2 - Process &amp; data handling, budget 3:00] [~15s] Cleaning removed just 0.38% of rows - ghost rows and synthetic test IDs - and zero cells were imputed, because inventing a salary would contaminate the thing we're measuring. Salary coverage: 99.0%.</a:t>
+            </a:r>
+          </a:p>
+        </p:txBody>
+      </p:sp>
+      <p:sp>
+        <p:nvSpPr>
+          <p:cNvPr id="4" name="Slide Number Placeholder 3"/>
+          <p:cNvSpPr>
+            <a:spLocks noGrp="1"/>
+          </p:cNvSpPr>
+          <p:nvPr>
+            <p:ph type="sldNum" idx="5" sz="quarter"/>
+          </p:nvPr>
+        </p:nvSpPr>
+        <p:spPr/>
+      </p:sp>
+    </p:spTree>
+  </p:cSld>
+  <p:clrMapOvr>
+    <a:masterClrMapping/>
+  </p:clrMapOvr>
+</p:notes>
+</file>
+
+<file path=ppt/notesSlides/notesSlide5.xml><?xml version="1.0" encoding="utf-8"?>
+<p:notes xmlns:a="http://schemas.openxmlformats.org/drawingml/2006/main" xmlns:p="http://schemas.openxmlformats.org/presentationml/2006/main" xmlns:r="http://schemas.openxmlformats.org/officeDocument/2006/relationships">
+  <p:cSld>
+    <p:spTree>
+      <p:nvGrpSpPr>
+        <p:cNvPr id="1" name=""/>
+        <p:cNvGrpSpPr/>
+        <p:nvPr/>
+      </p:nvGrpSpPr>
+      <p:grpSpPr>
+        <a:xfrm>
+          <a:off x="0" y="0"/>
+          <a:ext cx="0" cy="0"/>
+          <a:chOff x="0" y="0"/>
+          <a:chExt cx="0" cy="0"/>
+        </a:xfrm>
+      </p:grpSpPr>
+      <p:sp>
+        <p:nvSpPr>
+          <p:cNvPr id="2" name="Slide Image Placeholder 1"/>
+          <p:cNvSpPr>
+            <a:spLocks noGrp="1"/>
+          </p:cNvSpPr>
+          <p:nvPr>
+            <p:ph type="sldImg" idx="2"/>
+          </p:nvPr>
+        </p:nvSpPr>
+        <p:spPr/>
+      </p:sp>
+      <p:sp>
+        <p:nvSpPr>
+          <p:cNvPr id="3" name="Notes Placeholder 2"/>
+          <p:cNvSpPr>
+            <a:spLocks noGrp="1"/>
+          </p:cNvSpPr>
+          <p:nvPr>
+            <p:ph type="body" idx="3" sz="quarter"/>
+          </p:nvPr>
+        </p:nvSpPr>
+        <p:spPr/>
+        <p:txBody>
+          <a:bodyPr/>
+          <a:lstStyle/>
+          <a:p>
+            <a:r>
+              <a:t>[~25s] Two edge cases, same rule. $1-to-$1 postings - 1,804 of them - are placeholder junk, so they're nulled. $150,000-a-month postings - 269 of them - might be real, might be a typo, so they're flagged and kept, filterable in one line depending on the question being asked.</a:t>
+            </a:r>
+          </a:p>
+        </p:txBody>
+      </p:sp>
+      <p:sp>
+        <p:nvSpPr>
+          <p:cNvPr id="4" name="Slide Number Placeholder 3"/>
+          <p:cNvSpPr>
+            <a:spLocks noGrp="1"/>
+          </p:cNvSpPr>
+          <p:nvPr>
+            <p:ph type="sldNum" idx="5" sz="quarter"/>
+          </p:nvPr>
+        </p:nvSpPr>
+        <p:spPr/>
+      </p:sp>
+    </p:spTree>
+  </p:cSld>
+  <p:clrMapOvr>
+    <a:masterClrMapping/>
+  </p:clrMapOvr>
+</p:notes>
+</file>
+
+<file path=ppt/notesSlides/notesSlide6.xml><?xml version="1.0" encoding="utf-8"?>
+<p:notes xmlns:a="http://schemas.openxmlformats.org/drawingml/2006/main" xmlns:p="http://schemas.openxmlformats.org/presentationml/2006/main" xmlns:r="http://schemas.openxmlformats.org/officeDocument/2006/relationships">
+  <p:cSld>
+    <p:spTree>
+      <p:nvGrpSpPr>
+        <p:cNvPr id="1" name=""/>
+        <p:cNvGrpSpPr/>
+        <p:nvPr/>
+      </p:nvGrpSpPr>
+      <p:grpSpPr>
+        <a:xfrm>
+          <a:off x="0" y="0"/>
+          <a:ext cx="0" cy="0"/>
+          <a:chOff x="0" y="0"/>
+          <a:chExt cx="0" cy="0"/>
+        </a:xfrm>
+      </p:grpSpPr>
+      <p:sp>
+        <p:nvSpPr>
+          <p:cNvPr id="2" name="Slide Image Placeholder 1"/>
+          <p:cNvSpPr>
+            <a:spLocks noGrp="1"/>
+          </p:cNvSpPr>
+          <p:nvPr>
+            <p:ph type="sldImg" idx="2"/>
+          </p:nvPr>
+        </p:nvSpPr>
+        <p:spPr/>
+      </p:sp>
+      <p:sp>
+        <p:nvSpPr>
+          <p:cNvPr id="3" name="Notes Placeholder 2"/>
+          <p:cNvSpPr>
+            <a:spLocks noGrp="1"/>
+          </p:cNvSpPr>
+          <p:nvPr>
+            <p:ph type="body" idx="3" sz="quarter"/>
+          </p:nvPr>
+        </p:nvSpPr>
+        <p:spPr/>
+        <p:txBody>
+          <a:bodyPr/>
+          <a:lstStyle/>
+          <a:p>
+            <a:r>
+              <a:t>[~30s] Four fixes that change the answer, not just the format. Dates: parsed, reformatted, and compared - any mismatch refuses the conversion. Text: invisible zero-width characters split 184 titles in two. Duplicates: 16,990 of 21,344 same-day groups had different view counts - real listings, so flagged, not dropped. Categories: exploding the JSON array instead of keeping just the first value preserved 723,000 category assignments.</a:t>
+            </a:r>
+          </a:p>
+        </p:txBody>
+      </p:sp>
+      <p:sp>
+        <p:nvSpPr>
+          <p:cNvPr id="4" name="Slide Number Placeholder 3"/>
+          <p:cNvSpPr>
+            <a:spLocks noGrp="1"/>
+          </p:cNvSpPr>
+          <p:nvPr>
+            <p:ph type="sldNum" idx="5" sz="quarter"/>
+          </p:nvPr>
+        </p:nvSpPr>
+        <p:spPr/>
+      </p:sp>
+    </p:spTree>
+  </p:cSld>
+  <p:clrMapOvr>
+    <a:masterClrMapping/>
+  </p:clrMapOvr>
+</p:notes>
+</file>
+
+<file path=ppt/notesSlides/notesSlide7.xml><?xml version="1.0" encoding="utf-8"?>
+<p:notes xmlns:a="http://schemas.openxmlformats.org/drawingml/2006/main" xmlns:p="http://schemas.openxmlformats.org/presentationml/2006/main" xmlns:r="http://schemas.openxmlformats.org/officeDocument/2006/relationships">
+  <p:cSld>
+    <p:spTree>
+      <p:nvGrpSpPr>
+        <p:cNvPr id="1" name=""/>
+        <p:cNvGrpSpPr/>
+        <p:nvPr/>
+      </p:nvGrpSpPr>
+      <p:grpSpPr>
+        <a:xfrm>
+          <a:off x="0" y="0"/>
+          <a:ext cx="0" cy="0"/>
+          <a:chOff x="0" y="0"/>
+          <a:chExt cx="0" cy="0"/>
+        </a:xfrm>
+      </p:grpSpPr>
+      <p:sp>
+        <p:nvSpPr>
+          <p:cNvPr id="2" name="Slide Image Placeholder 1"/>
+          <p:cNvSpPr>
+            <a:spLocks noGrp="1"/>
+          </p:cNvSpPr>
+          <p:nvPr>
+            <p:ph type="sldImg" idx="2"/>
+          </p:nvPr>
+        </p:nvSpPr>
+        <p:spPr/>
+      </p:sp>
+      <p:sp>
+        <p:nvSpPr>
+          <p:cNvPr id="3" name="Notes Placeholder 2"/>
+          <p:cNvSpPr>
+            <a:spLocks noGrp="1"/>
+          </p:cNvSpPr>
+          <p:nvPr>
+            <p:ph type="body" idx="3" sz="quarter"/>
+          </p:nvPr>
+        </p:nvSpPr>
+        <p:spPr/>
+        <p:txBody>
+          <a:bodyPr/>
+          <a:lstStyle/>
+          <a:p>
+            <a:r>
+              <a:t>[~30s] The finding that shaped the product. Median views collapse from 51 in June 2023 to just 2 in July - and a July posting has had ten extra months to accumulate views, yet has fewer. That only makes sense if counters freeze at day zero after a crawl boundary. Those postings aren't low-response - they're unmeasured. That's why the response cohort has to end before the boundary.</a:t>
+            </a:r>
+          </a:p>
+        </p:txBody>
+      </p:sp>
+      <p:sp>
+        <p:nvSpPr>
+          <p:cNvPr id="4" name="Slide Number Placeholder 3"/>
+          <p:cNvSpPr>
+            <a:spLocks noGrp="1"/>
+          </p:cNvSpPr>
+          <p:nvPr>
+            <p:ph type="sldNum" idx="5" sz="quarter"/>
+          </p:nvPr>
+        </p:nvSpPr>
+        <p:spPr/>
+      </p:sp>
+    </p:spTree>
+  </p:cSld>
+  <p:clrMapOvr>
+    <a:masterClrMapping/>
+  </p:clrMapOvr>
+</p:notes>
+</file>
+
+<file path=ppt/notesSlides/notesSlide8.xml><?xml version="1.0" encoding="utf-8"?>
+<p:notes xmlns:a="http://schemas.openxmlformats.org/drawingml/2006/main" xmlns:p="http://schemas.openxmlformats.org/presentationml/2006/main" xmlns:r="http://schemas.openxmlformats.org/officeDocument/2006/relationships">
+  <p:cSld>
+    <p:spTree>
+      <p:nvGrpSpPr>
+        <p:cNvPr id="1" name=""/>
+        <p:cNvGrpSpPr/>
+        <p:nvPr/>
+      </p:nvGrpSpPr>
+      <p:grpSpPr>
+        <a:xfrm>
+          <a:off x="0" y="0"/>
+          <a:ext cx="0" cy="0"/>
+          <a:chOff x="0" y="0"/>
+          <a:chExt cx="0" cy="0"/>
+        </a:xfrm>
+      </p:grpSpPr>
+      <p:sp>
+        <p:nvSpPr>
+          <p:cNvPr id="2" name="Slide Image Placeholder 1"/>
+          <p:cNvSpPr>
+            <a:spLocks noGrp="1"/>
+          </p:cNvSpPr>
+          <p:nvPr>
+            <p:ph type="sldImg" idx="2"/>
+          </p:nvPr>
+        </p:nvSpPr>
+        <p:spPr/>
+      </p:sp>
+      <p:sp>
+        <p:nvSpPr>
+          <p:cNvPr id="3" name="Notes Placeholder 2"/>
+          <p:cNvSpPr>
+            <a:spLocks noGrp="1"/>
+          </p:cNvSpPr>
+          <p:nvPr>
+            <p:ph type="body" idx="3" sz="quarter"/>
+          </p:nvPr>
+        </p:nvSpPr>
+        <p:spPr/>
+        <p:txBody>
+          <a:bodyPr/>
+          <a:lstStyle/>
+          <a:p>
+            <a:r>
+              <a:t>[~25s] The funnel: 1,044,587 cleaned, 1,009,709 deduplicated - that's Layer 1, the whole market. Then 118,749 with complete counters, 96,028 thirty-day listings for repost risk, and 78,942 first-cycle listings for views and applications - that's Layer 2. Each metric uses the smallest cohort that's still defensible.</a:t>
+            </a:r>
+          </a:p>
+        </p:txBody>
+      </p:sp>
+      <p:sp>
+        <p:nvSpPr>
+          <p:cNvPr id="4" name="Slide Number Placeholder 3"/>
+          <p:cNvSpPr>
+            <a:spLocks noGrp="1"/>
+          </p:cNvSpPr>
+          <p:nvPr>
+            <p:ph type="sldNum" idx="5" sz="quarter"/>
+          </p:nvPr>
+        </p:nvSpPr>
+        <p:spPr/>
+      </p:sp>
+    </p:spTree>
+  </p:cSld>
+  <p:clrMapOvr>
+    <a:masterClrMapping/>
+  </p:clrMapOvr>
+</p:notes>
+</file>
+
+<file path=ppt/notesSlides/notesSlide9.xml><?xml version="1.0" encoding="utf-8"?>
+<p:notes xmlns:a="http://schemas.openxmlformats.org/drawingml/2006/main" xmlns:p="http://schemas.openxmlformats.org/presentationml/2006/main" xmlns:r="http://schemas.openxmlformats.org/officeDocument/2006/relationships">
+  <p:cSld>
+    <p:spTree>
+      <p:nvGrpSpPr>
+        <p:cNvPr id="1" name=""/>
+        <p:cNvGrpSpPr/>
+        <p:nvPr/>
+      </p:nvGrpSpPr>
+      <p:grpSpPr>
+        <a:xfrm>
+          <a:off x="0" y="0"/>
+          <a:ext cx="0" cy="0"/>
+          <a:chOff x="0" y="0"/>
+          <a:chExt cx="0" cy="0"/>
+        </a:xfrm>
+      </p:grpSpPr>
+      <p:sp>
+        <p:nvSpPr>
+          <p:cNvPr id="2" name="Slide Image Placeholder 1"/>
+          <p:cNvSpPr>
+            <a:spLocks noGrp="1"/>
+          </p:cNvSpPr>
+          <p:nvPr>
+            <p:ph type="sldImg" idx="2"/>
+          </p:nvPr>
+        </p:nvSpPr>
+        <p:spPr/>
+      </p:sp>
+      <p:sp>
+        <p:nvSpPr>
+          <p:cNvPr id="3" name="Notes Placeholder 2"/>
+          <p:cNvSpPr>
+            <a:spLocks noGrp="1"/>
+          </p:cNvSpPr>
+          <p:nvPr>
+            <p:ph type="body" idx="3" sz="quarter"/>
+          </p:nvPr>
+        </p:nvSpPr>
+        <p:spPr/>
+        <p:txBody>
+          <a:bodyPr/>
+          <a:lstStyle/>
+          <a:p>
+            <a:r>
+              <a:t>[~20s] One pipeline: CSV, clean, enrich, DuckDB, Streamlit, four boards. Notebook and dashboard import the same tested pipeline code, so they can't drift apart. DuckDB is what makes a million-row aggregation happen inside a click.</a:t>
+            </a:r>
+          </a:p>
+        </p:txBody>
+      </p:sp>
+      <p:sp>
+        <p:nvSpPr>
+          <p:cNvPr id="4" name="Slide Number Placeholder 3"/>
+          <p:cNvSpPr>
+            <a:spLocks noGrp="1"/>
+          </p:cNvSpPr>
+          <p:nvPr>
+            <p:ph type="sldNum" idx="5" sz="quarter"/>
+          </p:nvPr>
+        </p:nvSpPr>
+        <p:spPr/>
+      </p:sp>
+    </p:spTree>
+  </p:cSld>
+  <p:clrMapOvr>
+    <a:masterClrMapping/>
+  </p:clrMapOvr>
+</p:notes>
 </file>
 
 <file path=ppt/slideLayouts/slideLayout1.xml><?xml version="1.0" encoding="utf-8"?>
@@ -25125,4 +26455,324 @@
     </a:fmtScheme>
   </a:themeElements>
 </a:theme>
+</file>
+
+<file path=ppt/theme/theme2.xml><?xml version="1.0" encoding="utf-8"?>
+<a:theme xmlns:a="http://schemas.openxmlformats.org/drawingml/2006/main" name="Office Theme">
+  <a:themeElements>
+    <a:clrScheme name="Office">
+      <a:dk1>
+        <a:sysClr val="windowText" lastClr="000000"/>
+      </a:dk1>
+      <a:lt1>
+        <a:sysClr val="window" lastClr="FFFFFF"/>
+      </a:lt1>
+      <a:dk2>
+        <a:srgbClr val="1F497D"/>
+      </a:dk2>
+      <a:lt2>
+        <a:srgbClr val="EEECE1"/>
+      </a:lt2>
+      <a:accent1>
+        <a:srgbClr val="4F81BD"/>
+      </a:accent1>
+      <a:accent2>
+        <a:srgbClr val="C0504D"/>
+      </a:accent2>
+      <a:accent3>
+        <a:srgbClr val="9BBB59"/>
+      </a:accent3>
+      <a:accent4>
+        <a:srgbClr val="8064A2"/>
+      </a:accent4>
+      <a:accent5>
+        <a:srgbClr val="4BACC6"/>
+      </a:accent5>
+      <a:accent6>
+        <a:srgbClr val="F79646"/>
+      </a:accent6>
+      <a:hlink>
+        <a:srgbClr val="0000FF"/>
+      </a:hlink>
+      <a:folHlink>
+        <a:srgbClr val="800080"/>
+      </a:folHlink>
+    </a:clrScheme>
+    <a:fontScheme name="Office">
+      <a:majorFont>
+        <a:latin typeface="Calibri"/>
+        <a:ea typeface=""/>
+        <a:cs typeface=""/>
+        <a:font script="Jpan" typeface="ＭＳ Ｐゴシック"/>
+        <a:font script="Hang" typeface="맑은 고딕"/>
+        <a:font script="Hans" typeface="宋体"/>
+        <a:font script="Hant" typeface="新細明體"/>
+        <a:font script="Arab" typeface="Times New Roman"/>
+        <a:font script="Hebr" typeface="Times New Roman"/>
+        <a:font script="Thai" typeface="Angsana New"/>
+        <a:font script="Ethi" typeface="Nyala"/>
+        <a:font script="Beng" typeface="Vrinda"/>
+        <a:font script="Gujr" typeface="Shruti"/>
+        <a:font script="Khmr" typeface="MoolBoran"/>
+        <a:font script="Knda" typeface="Tunga"/>
+        <a:font script="Guru" typeface="Raavi"/>
+        <a:font script="Cans" typeface="Euphemia"/>
+        <a:font script="Cher" typeface="Plantagenet Cherokee"/>
+        <a:font script="Yiii" typeface="Microsoft Yi Baiti"/>
+        <a:font script="Tibt" typeface="Microsoft Himalaya"/>
+        <a:font script="Thaa" typeface="MV Boli"/>
+        <a:font script="Deva" typeface="Mangal"/>
+        <a:font script="Telu" typeface="Gautami"/>
+        <a:font script="Taml" typeface="Latha"/>
+        <a:font script="Syrc" typeface="Estrangelo Edessa"/>
+        <a:font script="Orya" typeface="Kalinga"/>
+        <a:font script="Mlym" typeface="Kartika"/>
+        <a:font script="Laoo" typeface="DokChampa"/>
+        <a:font script="Sinh" typeface="Iskoola Pota"/>
+        <a:font script="Mong" typeface="Mongolian Baiti"/>
+        <a:font script="Viet" typeface="Times New Roman"/>
+        <a:font script="Uigh" typeface="Microsoft Uighur"/>
+        <a:font script="Geor" typeface="Sylfaen"/>
+      </a:majorFont>
+      <a:minorFont>
+        <a:latin typeface="Calibri"/>
+        <a:ea typeface=""/>
+        <a:cs typeface=""/>
+        <a:font script="Jpan" typeface="ＭＳ Ｐゴシック"/>
+        <a:font script="Hang" typeface="맑은 고딕"/>
+        <a:font script="Hans" typeface="宋体"/>
+        <a:font script="Hant" typeface="新細明體"/>
+        <a:font script="Arab" typeface="Arial"/>
+        <a:font script="Hebr" typeface="Arial"/>
+        <a:font script="Thai" typeface="Cordia New"/>
+        <a:font script="Ethi" typeface="Nyala"/>
+        <a:font script="Beng" typeface="Vrinda"/>
+        <a:font script="Gujr" typeface="Shruti"/>
+        <a:font script="Khmr" typeface="DaunPenh"/>
+        <a:font script="Knda" typeface="Tunga"/>
+        <a:font script="Guru" typeface="Raavi"/>
+        <a:font script="Cans" typeface="Euphemia"/>
+        <a:font script="Cher" typeface="Plantagenet Cherokee"/>
+        <a:font script="Yiii" typeface="Microsoft Yi Baiti"/>
+        <a:font script="Tibt" typeface="Microsoft Himalaya"/>
+        <a:font script="Thaa" typeface="MV Boli"/>
+        <a:font script="Deva" typeface="Mangal"/>
+        <a:font script="Telu" typeface="Gautami"/>
+        <a:font script="Taml" typeface="Latha"/>
+        <a:font script="Syrc" typeface="Estrangelo Edessa"/>
+        <a:font script="Orya" typeface="Kalinga"/>
+        <a:font script="Mlym" typeface="Kartika"/>
+        <a:font script="Laoo" typeface="DokChampa"/>
+        <a:font script="Sinh" typeface="Iskoola Pota"/>
+        <a:font script="Mong" typeface="Mongolian Baiti"/>
+        <a:font script="Viet" typeface="Arial"/>
+        <a:font script="Uigh" typeface="Microsoft Uighur"/>
+        <a:font script="Geor" typeface="Sylfaen"/>
+      </a:minorFont>
+    </a:fontScheme>
+    <a:fmtScheme name="Office">
+      <a:fillStyleLst>
+        <a:solidFill>
+          <a:schemeClr val="phClr"/>
+        </a:solidFill>
+        <a:gradFill rotWithShape="1">
+          <a:gsLst>
+            <a:gs pos="0">
+              <a:schemeClr val="phClr">
+                <a:tint val="50000"/>
+                <a:satMod val="300000"/>
+              </a:schemeClr>
+            </a:gs>
+            <a:gs pos="35000">
+              <a:schemeClr val="phClr">
+                <a:tint val="37000"/>
+                <a:satMod val="300000"/>
+              </a:schemeClr>
+            </a:gs>
+            <a:gs pos="100000">
+              <a:schemeClr val="phClr">
+                <a:tint val="15000"/>
+                <a:satMod val="350000"/>
+              </a:schemeClr>
+            </a:gs>
+          </a:gsLst>
+          <a:lin ang="16200000" scaled="1"/>
+        </a:gradFill>
+        <a:gradFill rotWithShape="1">
+          <a:gsLst>
+            <a:gs pos="0">
+              <a:schemeClr val="phClr">
+                <a:tint val="100000"/>
+                <a:shade val="100000"/>
+                <a:satMod val="130000"/>
+              </a:schemeClr>
+            </a:gs>
+            <a:gs pos="100000">
+              <a:schemeClr val="phClr">
+                <a:tint val="50000"/>
+                <a:shade val="100000"/>
+                <a:satMod val="350000"/>
+              </a:schemeClr>
+            </a:gs>
+          </a:gsLst>
+          <a:lin ang="16200000" scaled="0"/>
+        </a:gradFill>
+      </a:fillStyleLst>
+      <a:lnStyleLst>
+        <a:ln w="9525" cap="flat" cmpd="sng" algn="ctr">
+          <a:solidFill>
+            <a:schemeClr val="phClr">
+              <a:shade val="95000"/>
+              <a:satMod val="105000"/>
+            </a:schemeClr>
+          </a:solidFill>
+          <a:prstDash val="solid"/>
+        </a:ln>
+        <a:ln w="25400" cap="flat" cmpd="sng" algn="ctr">
+          <a:solidFill>
+            <a:schemeClr val="phClr"/>
+          </a:solidFill>
+          <a:prstDash val="solid"/>
+        </a:ln>
+        <a:ln w="38100" cap="flat" cmpd="sng" algn="ctr">
+          <a:solidFill>
+            <a:schemeClr val="phClr"/>
+          </a:solidFill>
+          <a:prstDash val="solid"/>
+        </a:ln>
+      </a:lnStyleLst>
+      <a:effectStyleLst>
+        <a:effectStyle>
+          <a:effectLst>
+            <a:outerShdw blurRad="40000" dist="20000" dir="5400000" rotWithShape="0">
+              <a:srgbClr val="000000">
+                <a:alpha val="38000"/>
+              </a:srgbClr>
+            </a:outerShdw>
+          </a:effectLst>
+        </a:effectStyle>
+        <a:effectStyle>
+          <a:effectLst>
+            <a:outerShdw blurRad="40000" dist="23000" dir="5400000" rotWithShape="0">
+              <a:srgbClr val="000000">
+                <a:alpha val="35000"/>
+              </a:srgbClr>
+            </a:outerShdw>
+          </a:effectLst>
+        </a:effectStyle>
+        <a:effectStyle>
+          <a:effectLst>
+            <a:outerShdw blurRad="40000" dist="23000" dir="5400000" rotWithShape="0">
+              <a:srgbClr val="000000">
+                <a:alpha val="35000"/>
+              </a:srgbClr>
+            </a:outerShdw>
+          </a:effectLst>
+          <a:scene3d>
+            <a:camera prst="orthographicFront">
+              <a:rot lat="0" lon="0" rev="0"/>
+            </a:camera>
+            <a:lightRig rig="threePt" dir="t">
+              <a:rot lat="0" lon="0" rev="1200000"/>
+            </a:lightRig>
+          </a:scene3d>
+          <a:sp3d>
+            <a:bevelT w="63500" h="25400"/>
+          </a:sp3d>
+        </a:effectStyle>
+      </a:effectStyleLst>
+      <a:bgFillStyleLst>
+        <a:solidFill>
+          <a:schemeClr val="phClr"/>
+        </a:solidFill>
+        <a:gradFill rotWithShape="1">
+          <a:gsLst>
+            <a:gs pos="0">
+              <a:schemeClr val="phClr">
+                <a:tint val="40000"/>
+                <a:satMod val="350000"/>
+              </a:schemeClr>
+            </a:gs>
+            <a:gs pos="40000">
+              <a:schemeClr val="phClr">
+                <a:tint val="45000"/>
+                <a:shade val="99000"/>
+                <a:satMod val="350000"/>
+              </a:schemeClr>
+            </a:gs>
+            <a:gs pos="100000">
+              <a:schemeClr val="phClr">
+                <a:shade val="20000"/>
+                <a:satMod val="255000"/>
+              </a:schemeClr>
+            </a:gs>
+          </a:gsLst>
+          <a:path path="circle">
+            <a:fillToRect l="50000" t="-80000" r="50000" b="180000"/>
+          </a:path>
+        </a:gradFill>
+        <a:gradFill rotWithShape="1">
+          <a:gsLst>
+            <a:gs pos="0">
+              <a:schemeClr val="phClr">
+                <a:tint val="80000"/>
+                <a:satMod val="300000"/>
+              </a:schemeClr>
+            </a:gs>
+            <a:gs pos="100000">
+              <a:schemeClr val="phClr">
+                <a:shade val="30000"/>
+                <a:satMod val="200000"/>
+              </a:schemeClr>
+            </a:gs>
+          </a:gsLst>
+          <a:path path="circle">
+            <a:fillToRect l="50000" t="50000" r="50000" b="50000"/>
+          </a:path>
+        </a:gradFill>
+      </a:bgFillStyleLst>
+    </a:fmtScheme>
+  </a:themeElements>
+  <a:objectDefaults>
+    <a:spDef>
+      <a:spPr/>
+      <a:bodyPr/>
+      <a:lstStyle/>
+      <a:style>
+        <a:lnRef idx="1">
+          <a:schemeClr val="accent1"/>
+        </a:lnRef>
+        <a:fillRef idx="3">
+          <a:schemeClr val="accent1"/>
+        </a:fillRef>
+        <a:effectRef idx="2">
+          <a:schemeClr val="accent1"/>
+        </a:effectRef>
+        <a:fontRef idx="minor">
+          <a:schemeClr val="lt1"/>
+        </a:fontRef>
+      </a:style>
+    </a:spDef>
+    <a:lnDef>
+      <a:spPr/>
+      <a:bodyPr/>
+      <a:lstStyle/>
+      <a:style>
+        <a:lnRef idx="2">
+          <a:schemeClr val="accent1"/>
+        </a:lnRef>
+        <a:fillRef idx="0">
+          <a:schemeClr val="accent1"/>
+        </a:fillRef>
+        <a:effectRef idx="1">
+          <a:schemeClr val="accent1"/>
+        </a:effectRef>
+        <a:fontRef idx="minor">
+          <a:schemeClr val="tx1"/>
+        </a:fontRef>
+      </a:style>
+    </a:lnDef>
+  </a:objectDefaults>
+  <a:extraClrSchemeLst/>
+</a:theme>
 </file>
</xml_diff>